<commit_message>
adding minematics math slide explanation for week 3
</commit_message>
<xml_diff>
--- a/week03_kinematics/GAZEBO_AND_KINEMATICS.pptx
+++ b/week03_kinematics/GAZEBO_AND_KINEMATICS.pptx
@@ -19,6 +19,7 @@
     <p:sldId id="264" r:id="rId10"/>
     <p:sldId id="265" r:id="rId11"/>
     <p:sldId id="266" r:id="rId12"/>
+    <p:sldId id="274" r:id="rId25"/>
     <p:sldId id="267" r:id="rId13"/>
     <p:sldId id="268" r:id="rId14"/>
     <p:sldId id="269" r:id="rId15"/>
@@ -1888,6 +1889,76 @@
         <p14:creationId xmlns:p14="http://schemas.microsoft.com/office/powerpoint/2010/main" val="3981038994"/>
       </p:ext>
     </p:extLst>
+  </p:cSld>
+  <p:clrMapOvr>
+    <a:masterClrMapping/>
+  </p:clrMapOvr>
+</p:notes>
+</file>
+
+<file path=ppt/notesSlides/notesSlide19.xml><?xml version="1.0" encoding="utf-8"?>
+<p:notes xmlns:a="http://schemas.openxmlformats.org/drawingml/2006/main" xmlns:p="http://schemas.openxmlformats.org/presentationml/2006/main" xmlns:r="http://schemas.openxmlformats.org/officeDocument/2006/relationships">
+  <p:cSld>
+    <p:spTree>
+      <p:nvGrpSpPr>
+        <p:cNvPr id="1" name=""/>
+        <p:cNvGrpSpPr/>
+        <p:nvPr/>
+      </p:nvGrpSpPr>
+      <p:grpSpPr>
+        <a:xfrm>
+          <a:off x="0" y="0"/>
+          <a:ext cx="0" cy="0"/>
+          <a:chOff x="0" y="0"/>
+          <a:chExt cx="0" cy="0"/>
+        </a:xfrm>
+      </p:grpSpPr>
+      <p:sp>
+        <p:nvSpPr>
+          <p:cNvPr id="2" name="Slide Image Placeholder 1"/>
+          <p:cNvSpPr>
+            <a:spLocks noGrp="1"/>
+          </p:cNvSpPr>
+          <p:nvPr>
+            <p:ph type="sldImg" idx="2"/>
+          </p:nvPr>
+        </p:nvSpPr>
+        <p:spPr/>
+      </p:sp>
+      <p:sp>
+        <p:nvSpPr>
+          <p:cNvPr id="3" name="Notes Placeholder 2"/>
+          <p:cNvSpPr>
+            <a:spLocks noGrp="1"/>
+          </p:cNvSpPr>
+          <p:nvPr>
+            <p:ph type="body" idx="3" sz="quarter"/>
+          </p:nvPr>
+        </p:nvSpPr>
+        <p:spPr/>
+        <p:txBody>
+          <a:bodyPr/>
+          <a:lstStyle/>
+          <a:p>
+            <a:r>
+              <a:t>Geometry of planar forward kinematics. The supplied diagram uses theta_1 and theta_2 for q1 and q2. Each link contributes its horizontal cosine and vertical sine projection; the second link has absolute angle theta_1 + theta_2.</a:t>
+            </a:r>
+          </a:p>
+        </p:txBody>
+      </p:sp>
+      <p:sp>
+        <p:nvSpPr>
+          <p:cNvPr id="4" name="Slide Number Placeholder 3"/>
+          <p:cNvSpPr>
+            <a:spLocks noGrp="1"/>
+          </p:cNvSpPr>
+          <p:nvPr>
+            <p:ph type="sldNum" idx="5" sz="quarter"/>
+          </p:nvPr>
+        </p:nvSpPr>
+        <p:spPr/>
+      </p:sp>
+    </p:spTree>
   </p:cSld>
   <p:clrMapOvr>
     <a:masterClrMapping/>
@@ -22737,6 +22808,56 @@
         <p14:creationId xmlns:p14="http://schemas.microsoft.com/office/powerpoint/2010/main" val="462498310"/>
       </p:ext>
     </p:extLst>
+  </p:cSld>
+  <p:clrMapOvr>
+    <a:masterClrMapping/>
+  </p:clrMapOvr>
+</p:sld>
+</file>
+
+<file path=ppt/slides/slide19.xml><?xml version="1.0" encoding="utf-8"?>
+<p:sld xmlns:a="http://schemas.openxmlformats.org/drawingml/2006/main" xmlns:p="http://schemas.openxmlformats.org/presentationml/2006/main" xmlns:r="http://schemas.openxmlformats.org/officeDocument/2006/relationships" showMasterSp="0">
+  <p:cSld>
+    <p:bg>
+      <p:bgPr>
+        <a:solidFill>
+          <a:srgbClr val="FFFFFF"/>
+        </a:solidFill>
+        <a:effectLst/>
+      </p:bgPr>
+    </p:bg>
+    <p:spTree>
+      <p:nvGrpSpPr>
+        <p:cNvPr id="1" name=""/>
+        <p:cNvGrpSpPr/>
+        <p:nvPr/>
+      </p:nvGrpSpPr>
+      <p:grpSpPr/>
+      <p:pic>
+        <p:nvPicPr>
+          <p:cNvPr id="2" name="Picture 1" descr="forward_kinematics_geometry.jpg"/>
+          <p:cNvPicPr>
+            <a:picLocks noChangeAspect="1"/>
+          </p:cNvPicPr>
+          <p:nvPr/>
+        </p:nvPicPr>
+        <p:blipFill>
+          <a:blip r:embed="rId2"/>
+          <a:stretch>
+            <a:fillRect/>
+          </a:stretch>
+        </p:blipFill>
+        <p:spPr>
+          <a:xfrm>
+            <a:off x="1576725" y="0"/>
+            <a:ext cx="9038550" cy="6858000"/>
+          </a:xfrm>
+          <a:prstGeom prst="rect">
+            <a:avLst/>
+          </a:prstGeom>
+        </p:spPr>
+      </p:pic>
+    </p:spTree>
   </p:cSld>
   <p:clrMapOvr>
     <a:masterClrMapping/>

</xml_diff>